<commit_message>
Processed Week01 lectures for 8-25-26
</commit_message>
<xml_diff>
--- a/lecture_slides/Week1_Lecture2_Eigenfunctions_DTFT_082526_forClass.pptx
+++ b/lecture_slides/Week1_Lecture2_Eigenfunctions_DTFT_082526_forClass.pptx
@@ -453,6 +453,398 @@
 </c:chartSpace>
 </file>
 
+<file path=ppt/ink/ink1.xml><?xml version="1.0" encoding="utf-8"?>
+<inkml:ink xmlns:inkml="http://www.w3.org/2003/InkML">
+  <inkml:definitions>
+    <inkml:context xml:id="ctx0">
+      <inkml:inkSource xml:id="inkSrc0">
+        <inkml:traceFormat>
+          <inkml:channel name="X" type="integer" min="-2.14748E9" max="2.14748E9" units="cm"/>
+          <inkml:channel name="Y" type="integer" min="-2.14748E9" max="2.14748E9" units="cm"/>
+          <inkml:channel name="F" type="integer" max="32767" units="dev"/>
+        </inkml:traceFormat>
+        <inkml:channelProperties>
+          <inkml:channelProperty channel="X" name="resolution" value="1000" units="1/cm"/>
+          <inkml:channelProperty channel="Y" name="resolution" value="1000" units="1/cm"/>
+          <inkml:channelProperty channel="F" name="resolution" value="0" units="1/dev"/>
+        </inkml:channelProperties>
+      </inkml:inkSource>
+      <inkml:timestamp xml:id="ts0" timeString="2026-08-25T18:24:47.748"/>
+    </inkml:context>
+    <inkml:brush xml:id="br0">
+      <inkml:brushProperty name="width" value="0.05" units="cm"/>
+      <inkml:brushProperty name="height" value="0.05" units="cm"/>
+      <inkml:brushProperty name="color" value="#E71224"/>
+    </inkml:brush>
+  </inkml:definitions>
+  <inkml:trace contextRef="#ctx0" brushRef="#br0">1 1 24575,'0'0'-8191</inkml:trace>
+</inkml:ink>
+</file>
+
+<file path=ppt/ink/ink10.xml><?xml version="1.0" encoding="utf-8"?>
+<inkml:ink xmlns:inkml="http://www.w3.org/2003/InkML">
+  <inkml:definitions>
+    <inkml:context xml:id="ctx0">
+      <inkml:inkSource xml:id="inkSrc0">
+        <inkml:traceFormat>
+          <inkml:channel name="X" type="integer" min="-2.14748E9" max="2.14748E9" units="cm"/>
+          <inkml:channel name="Y" type="integer" min="-2.14748E9" max="2.14748E9" units="cm"/>
+          <inkml:channel name="F" type="integer" max="32767" units="dev"/>
+        </inkml:traceFormat>
+        <inkml:channelProperties>
+          <inkml:channelProperty channel="X" name="resolution" value="1000" units="1/cm"/>
+          <inkml:channelProperty channel="Y" name="resolution" value="1000" units="1/cm"/>
+          <inkml:channelProperty channel="F" name="resolution" value="0" units="1/dev"/>
+        </inkml:channelProperties>
+      </inkml:inkSource>
+      <inkml:timestamp xml:id="ts0" timeString="2026-08-25T16:41:47.784"/>
+    </inkml:context>
+    <inkml:brush xml:id="br0">
+      <inkml:brushProperty name="width" value="0.05" units="cm"/>
+      <inkml:brushProperty name="height" value="0.05" units="cm"/>
+      <inkml:brushProperty name="color" value="#E71224"/>
+    </inkml:brush>
+  </inkml:definitions>
+  <inkml:trace contextRef="#ctx0" brushRef="#br0">1 117 24575,'9'-17'0,"9"-6"0,4 2 0,0 3 0,1 6 0,0 4 0,-2 1 0,0 2 0,-1 2 0,-1 1 0,-1 2 0,-2-1 0,-1 2 0,-3-1-8191</inkml:trace>
+</inkml:ink>
+</file>
+
+<file path=ppt/ink/ink11.xml><?xml version="1.0" encoding="utf-8"?>
+<inkml:ink xmlns:inkml="http://www.w3.org/2003/InkML">
+  <inkml:definitions>
+    <inkml:context xml:id="ctx0">
+      <inkml:inkSource xml:id="inkSrc0">
+        <inkml:traceFormat>
+          <inkml:channel name="X" type="integer" min="-2.14748E9" max="2.14748E9" units="cm"/>
+          <inkml:channel name="Y" type="integer" min="-2.14748E9" max="2.14748E9" units="cm"/>
+          <inkml:channel name="F" type="integer" max="32767" units="dev"/>
+        </inkml:traceFormat>
+        <inkml:channelProperties>
+          <inkml:channelProperty channel="X" name="resolution" value="1000" units="1/cm"/>
+          <inkml:channelProperty channel="Y" name="resolution" value="1000" units="1/cm"/>
+          <inkml:channelProperty channel="F" name="resolution" value="0" units="1/dev"/>
+        </inkml:channelProperties>
+      </inkml:inkSource>
+      <inkml:timestamp xml:id="ts0" timeString="2026-08-25T16:41:48.113"/>
+    </inkml:context>
+    <inkml:brush xml:id="br0">
+      <inkml:brushProperty name="width" value="0.05" units="cm"/>
+      <inkml:brushProperty name="height" value="0.05" units="cm"/>
+      <inkml:brushProperty name="color" value="#E71224"/>
+    </inkml:brush>
+  </inkml:definitions>
+  <inkml:trace contextRef="#ctx0" brushRef="#br0">1 7 24575,'0'1'0,"0"0"0,0-1 0,1 1 0,-1-1 0,0 1 0,1 0 0,-1-1 0,0 1 0,1-1 0,-1 1 0,1-1 0,-1 1 0,1-1 0,-1 1 0,1-1 0,-1 0 0,1 1 0,0-1 0,-1 0 0,1 0 0,0 1 0,-1-1 0,1 0 0,0 0 0,-1 0 0,1 0 0,1 1 0,21 1 0,-20-2 0,22 1 0,-1-2 0,0-1 0,26-5 0,-40 5 0,11 0 43,12-2-1451,-23 1-5418</inkml:trace>
+</inkml:ink>
+</file>
+
+<file path=ppt/ink/ink12.xml><?xml version="1.0" encoding="utf-8"?>
+<inkml:ink xmlns:inkml="http://www.w3.org/2003/InkML">
+  <inkml:definitions>
+    <inkml:context xml:id="ctx0">
+      <inkml:inkSource xml:id="inkSrc0">
+        <inkml:traceFormat>
+          <inkml:channel name="X" type="integer" min="-2.14748E9" max="2.14748E9" units="cm"/>
+          <inkml:channel name="Y" type="integer" min="-2.14748E9" max="2.14748E9" units="cm"/>
+          <inkml:channel name="F" type="integer" max="32767" units="dev"/>
+        </inkml:traceFormat>
+        <inkml:channelProperties>
+          <inkml:channelProperty channel="X" name="resolution" value="1000" units="1/cm"/>
+          <inkml:channelProperty channel="Y" name="resolution" value="1000" units="1/cm"/>
+          <inkml:channelProperty channel="F" name="resolution" value="0" units="1/dev"/>
+        </inkml:channelProperties>
+      </inkml:inkSource>
+      <inkml:timestamp xml:id="ts0" timeString="2026-08-25T16:41:48.785"/>
+    </inkml:context>
+    <inkml:brush xml:id="br0">
+      <inkml:brushProperty name="width" value="0.05" units="cm"/>
+      <inkml:brushProperty name="height" value="0.05" units="cm"/>
+      <inkml:brushProperty name="color" value="#E71224"/>
+    </inkml:brush>
+  </inkml:definitions>
+  <inkml:trace contextRef="#ctx0" brushRef="#br0">0 0 24575,'2'10'0,"1"0"0,0 0 0,6 12 0,0-1 0,-7-13 0,45 112 0,-35-92 0,2-1 0,21 32 0,-31-53-101,-7-7 257,-8-9-520,8 7-692</inkml:trace>
+</inkml:ink>
+</file>
+
+<file path=ppt/ink/ink13.xml><?xml version="1.0" encoding="utf-8"?>
+<inkml:ink xmlns:inkml="http://www.w3.org/2003/InkML">
+  <inkml:definitions>
+    <inkml:context xml:id="ctx0">
+      <inkml:inkSource xml:id="inkSrc0">
+        <inkml:traceFormat>
+          <inkml:channel name="X" type="integer" min="-2.14748E9" max="2.14748E9" units="cm"/>
+          <inkml:channel name="Y" type="integer" min="-2.14748E9" max="2.14748E9" units="cm"/>
+          <inkml:channel name="F" type="integer" max="32767" units="dev"/>
+        </inkml:traceFormat>
+        <inkml:channelProperties>
+          <inkml:channelProperty channel="X" name="resolution" value="1000" units="1/cm"/>
+          <inkml:channelProperty channel="Y" name="resolution" value="1000" units="1/cm"/>
+          <inkml:channelProperty channel="F" name="resolution" value="0" units="1/dev"/>
+        </inkml:channelProperties>
+      </inkml:inkSource>
+      <inkml:timestamp xml:id="ts0" timeString="2026-08-25T16:41:49.206"/>
+    </inkml:context>
+    <inkml:brush xml:id="br0">
+      <inkml:brushProperty name="width" value="0.05" units="cm"/>
+      <inkml:brushProperty name="height" value="0.05" units="cm"/>
+      <inkml:brushProperty name="color" value="#E71224"/>
+    </inkml:brush>
+  </inkml:definitions>
+  <inkml:trace contextRef="#ctx0" brushRef="#br0">385 21 24575,'0'0'0,"-1"-1"0,1 1 0,0 0 0,0-1 0,-1 1 0,1-1 0,0 1 0,0 0 0,-1-1 0,1 1 0,0 0 0,-1 0 0,1-1 0,0 1 0,-1 0 0,1 0 0,-1-1 0,1 1 0,0 0 0,-1 0 0,1 0 0,-1 0 0,1 0 0,-1 0 0,1-1 0,-1 1 0,1 0 0,0 0 0,-1 0 0,1 1 0,-1-1 0,1 0 0,-1 0 0,-22 2 0,17-1 0,-49 1 0,-103-9 0,124 4 0,-42-3-1365,57 2-5461</inkml:trace>
+</inkml:ink>
+</file>
+
+<file path=ppt/ink/ink14.xml><?xml version="1.0" encoding="utf-8"?>
+<inkml:ink xmlns:inkml="http://www.w3.org/2003/InkML">
+  <inkml:definitions>
+    <inkml:context xml:id="ctx0">
+      <inkml:inkSource xml:id="inkSrc0">
+        <inkml:traceFormat>
+          <inkml:channel name="X" type="integer" min="-2.14748E9" max="2.14748E9" units="cm"/>
+          <inkml:channel name="Y" type="integer" min="-2.14748E9" max="2.14748E9" units="cm"/>
+          <inkml:channel name="F" type="integer" max="32767" units="dev"/>
+        </inkml:traceFormat>
+        <inkml:channelProperties>
+          <inkml:channelProperty channel="X" name="resolution" value="1000" units="1/cm"/>
+          <inkml:channelProperty channel="Y" name="resolution" value="1000" units="1/cm"/>
+          <inkml:channelProperty channel="F" name="resolution" value="0" units="1/dev"/>
+        </inkml:channelProperties>
+      </inkml:inkSource>
+      <inkml:timestamp xml:id="ts0" timeString="2026-08-25T16:44:13.481"/>
+    </inkml:context>
+    <inkml:brush xml:id="br0">
+      <inkml:brushProperty name="width" value="0.05" units="cm"/>
+      <inkml:brushProperty name="height" value="0.05" units="cm"/>
+      <inkml:brushProperty name="color" value="#E71224"/>
+    </inkml:brush>
+  </inkml:definitions>
+  <inkml:trace contextRef="#ctx0" brushRef="#br0">0 0 24575,'0'0'-8191</inkml:trace>
+</inkml:ink>
+</file>
+
+<file path=ppt/ink/ink2.xml><?xml version="1.0" encoding="utf-8"?>
+<inkml:ink xmlns:inkml="http://www.w3.org/2003/InkML">
+  <inkml:definitions>
+    <inkml:context xml:id="ctx0">
+      <inkml:inkSource xml:id="inkSrc0">
+        <inkml:traceFormat>
+          <inkml:channel name="X" type="integer" min="-2.14748E9" max="2.14748E9" units="cm"/>
+          <inkml:channel name="Y" type="integer" min="-2.14748E9" max="2.14748E9" units="cm"/>
+          <inkml:channel name="F" type="integer" max="32767" units="dev"/>
+        </inkml:traceFormat>
+        <inkml:channelProperties>
+          <inkml:channelProperty channel="X" name="resolution" value="1000" units="1/cm"/>
+          <inkml:channelProperty channel="Y" name="resolution" value="1000" units="1/cm"/>
+          <inkml:channelProperty channel="F" name="resolution" value="0" units="1/dev"/>
+        </inkml:channelProperties>
+      </inkml:inkSource>
+      <inkml:timestamp xml:id="ts0" timeString="2026-08-25T16:40:17.659"/>
+    </inkml:context>
+    <inkml:brush xml:id="br0">
+      <inkml:brushProperty name="width" value="0.05" units="cm"/>
+      <inkml:brushProperty name="height" value="0.05" units="cm"/>
+      <inkml:brushProperty name="color" value="#E71224"/>
+    </inkml:brush>
+  </inkml:definitions>
+  <inkml:trace contextRef="#ctx0" brushRef="#br0">1386 60 24575,'10'-3'0,"22"-7"0,-22 7 0,-10 3 0,0 0 0,0 0 0,0 0 0,0 0 0,0 0 0,0 0 0,0 0 0,0 0 0,0 0 0,0 0 0,-1 0 0,1 0 0,0 0 0,0 0 0,0 0 0,0 0 0,0 0 0,0 0 0,0 0 0,0-1 0,0 1 0,0 0 0,0 0 0,0 0 0,0 0 0,0 0 0,0 0 0,0 0 0,0 0 0,0 0 0,0 0 0,0 0 0,0 0 0,0 0 0,0 0 0,0 0 0,-364-4 0,-1-19 0,246 14 0,-268 3 0,240 7 0,145-1-62,0-1 0,-1 1 0,1 0 0,-1 1 0,1-1 0,-1 0 0,1 1 0,0-1 0,-1 1 0,1-1 0,0 1 0,0 0-1,-1 0 1,1 0 0,0 1 0,0-1 0,0 0 0,0 1 0,0-1 0,1 1 0,-4 2 0,1 5-6764</inkml:trace>
+</inkml:ink>
+</file>
+
+<file path=ppt/ink/ink3.xml><?xml version="1.0" encoding="utf-8"?>
+<inkml:ink xmlns:inkml="http://www.w3.org/2003/InkML">
+  <inkml:definitions>
+    <inkml:context xml:id="ctx0">
+      <inkml:inkSource xml:id="inkSrc0">
+        <inkml:traceFormat>
+          <inkml:channel name="X" type="integer" min="-2.14748E9" max="2.14748E9" units="cm"/>
+          <inkml:channel name="Y" type="integer" min="-2.14748E9" max="2.14748E9" units="cm"/>
+          <inkml:channel name="F" type="integer" max="32767" units="dev"/>
+        </inkml:traceFormat>
+        <inkml:channelProperties>
+          <inkml:channelProperty channel="X" name="resolution" value="1000" units="1/cm"/>
+          <inkml:channelProperty channel="Y" name="resolution" value="1000" units="1/cm"/>
+          <inkml:channelProperty channel="F" name="resolution" value="0" units="1/dev"/>
+        </inkml:channelProperties>
+      </inkml:inkSource>
+      <inkml:timestamp xml:id="ts0" timeString="2026-08-25T16:40:22.026"/>
+    </inkml:context>
+    <inkml:brush xml:id="br0">
+      <inkml:brushProperty name="width" value="0.05" units="cm"/>
+      <inkml:brushProperty name="height" value="0.05" units="cm"/>
+      <inkml:brushProperty name="color" value="#E71224"/>
+    </inkml:brush>
+  </inkml:definitions>
+  <inkml:trace contextRef="#ctx0" brushRef="#br0">1508 64 24575,'191'-41'0,"-183"40"0,6-1 0,-29 8 0,4-3 0,0 0 0,0-1 0,0 0 0,-16 0 0,-49-3 0,29 0 0,-177-8 0,-109-12 0,-587 22 0,895-4-1365,15 0-5461</inkml:trace>
+</inkml:ink>
+</file>
+
+<file path=ppt/ink/ink4.xml><?xml version="1.0" encoding="utf-8"?>
+<inkml:ink xmlns:inkml="http://www.w3.org/2003/InkML">
+  <inkml:definitions>
+    <inkml:context xml:id="ctx0">
+      <inkml:inkSource xml:id="inkSrc0">
+        <inkml:traceFormat>
+          <inkml:channel name="X" type="integer" min="-2.14748E9" max="2.14748E9" units="cm"/>
+          <inkml:channel name="Y" type="integer" min="-2.14748E9" max="2.14748E9" units="cm"/>
+          <inkml:channel name="F" type="integer" max="32767" units="dev"/>
+        </inkml:traceFormat>
+        <inkml:channelProperties>
+          <inkml:channelProperty channel="X" name="resolution" value="1000" units="1/cm"/>
+          <inkml:channelProperty channel="Y" name="resolution" value="1000" units="1/cm"/>
+          <inkml:channelProperty channel="F" name="resolution" value="0" units="1/dev"/>
+        </inkml:channelProperties>
+      </inkml:inkSource>
+      <inkml:timestamp xml:id="ts0" timeString="2026-08-25T16:41:19.464"/>
+    </inkml:context>
+    <inkml:brush xml:id="br0">
+      <inkml:brushProperty name="width" value="0.05" units="cm"/>
+      <inkml:brushProperty name="height" value="0.05" units="cm"/>
+      <inkml:brushProperty name="color" value="#E71224"/>
+    </inkml:brush>
+  </inkml:definitions>
+  <inkml:trace contextRef="#ctx0" brushRef="#br0">1169 58 24575,'62'-11'0,"91"-5"0,-142 16 0,-14 3 0,-18 3 0,-54 3 0,-1-4 0,-114-6 0,-443-46 0,572 42 0,-118 5 0,135 8 0,16-2 0,12-3 0,12-1 0,-1-1 0,1-1 0,-1 1 0,0-1 0,1 0 0,-1 0 0,1 0 0,-7-1 0,0-1-1365,1 0-5461</inkml:trace>
+</inkml:ink>
+</file>
+
+<file path=ppt/ink/ink5.xml><?xml version="1.0" encoding="utf-8"?>
+<inkml:ink xmlns:inkml="http://www.w3.org/2003/InkML">
+  <inkml:definitions>
+    <inkml:context xml:id="ctx0">
+      <inkml:inkSource xml:id="inkSrc0">
+        <inkml:traceFormat>
+          <inkml:channel name="X" type="integer" min="-2.14748E9" max="2.14748E9" units="cm"/>
+          <inkml:channel name="Y" type="integer" min="-2.14748E9" max="2.14748E9" units="cm"/>
+          <inkml:channel name="F" type="integer" max="32767" units="dev"/>
+        </inkml:traceFormat>
+        <inkml:channelProperties>
+          <inkml:channelProperty channel="X" name="resolution" value="1000" units="1/cm"/>
+          <inkml:channelProperty channel="Y" name="resolution" value="1000" units="1/cm"/>
+          <inkml:channelProperty channel="F" name="resolution" value="0" units="1/dev"/>
+        </inkml:channelProperties>
+      </inkml:inkSource>
+      <inkml:timestamp xml:id="ts0" timeString="2026-08-25T16:41:22.653"/>
+    </inkml:context>
+    <inkml:brush xml:id="br0">
+      <inkml:brushProperty name="width" value="0.05" units="cm"/>
+      <inkml:brushProperty name="height" value="0.05" units="cm"/>
+      <inkml:brushProperty name="color" value="#E71224"/>
+    </inkml:brush>
+  </inkml:definitions>
+  <inkml:trace contextRef="#ctx0" brushRef="#br0">1871 30 24575,'6'-4'0,"1"1"0,-1 0 0,1 0 0,-1 1 0,1 0 0,0 0 0,0 1 0,0 0 0,-1 0 0,1 0 0,0 1 0,0 0 0,0 1 0,0-1 0,0 1 0,0 1 0,10 2 0,-16-4 0,-1 0 0,1 0 0,-1 1 0,1-1 0,-1 0 0,1 0 0,-1 0 0,1 1 0,-1-1 0,1 0 0,-1 0 0,1 1 0,-1-1 0,0 0 0,1 1 0,-1-1 0,0 1 0,1-1 0,-1 1 0,0-1 0,1 0 0,-1 1 0,0-1 0,0 1 0,1 0 0,-2 0 0,1-1 0,0 1 0,0-1 0,-1 1 0,1-1 0,0 1 0,-1-1 0,1 0 0,0 1 0,-1-1 0,1 1 0,-1-1 0,1 0 0,0 1 0,-1-1 0,1 0 0,-1 1 0,0-1 0,-4 2 0,0 0 0,0 0 0,-9 1 0,-2-1 0,-1 0 0,-19-2 0,21-1 0,1 1 0,-1 1 0,-19 4 0,3-1 0,0 0 0,0-2 0,-46-3 0,28 0 0,-38-6 0,3 0 0,25 6 0,6 1 0,-64-8 0,54 3 0,-108 3 0,83 4 0,62-2 0,1-1 0,-39-7 0,30 3 0,1 3 0,-1 0 0,-35 4 0,6-1 0,-397-1 0,449-1 0,1 0 0,0 0 0,-12-4 0,-6-1 0,42 7 0,28-1 0,-24-1 0,33 3 0,179 20 0,-199-20 0,295 2 0,-187-5 0,46-8 0,-92 3 0,118 6 0,-130 7 0,27 1 0,222-8 0,-328-1-68,0 1 0,1 0-1,-1 0 1,0 1 0,1-1 0,-1 0-1,0 1 1,1-1 0,-1 1 0,0 0-1,0 0 1,0 0 0,1 0 0,-1 0-1,0 0 1,0 1 0,-1-1-1,1 1 1,2 2 0,3 4-6758</inkml:trace>
+</inkml:ink>
+</file>
+
+<file path=ppt/ink/ink6.xml><?xml version="1.0" encoding="utf-8"?>
+<inkml:ink xmlns:inkml="http://www.w3.org/2003/InkML">
+  <inkml:definitions>
+    <inkml:context xml:id="ctx0">
+      <inkml:inkSource xml:id="inkSrc0">
+        <inkml:traceFormat>
+          <inkml:channel name="X" type="integer" min="-2.14748E9" max="2.14748E9" units="cm"/>
+          <inkml:channel name="Y" type="integer" min="-2.14748E9" max="2.14748E9" units="cm"/>
+          <inkml:channel name="F" type="integer" max="32767" units="dev"/>
+        </inkml:traceFormat>
+        <inkml:channelProperties>
+          <inkml:channelProperty channel="X" name="resolution" value="1000" units="1/cm"/>
+          <inkml:channelProperty channel="Y" name="resolution" value="1000" units="1/cm"/>
+          <inkml:channelProperty channel="F" name="resolution" value="0" units="1/dev"/>
+        </inkml:channelProperties>
+      </inkml:inkSource>
+      <inkml:timestamp xml:id="ts0" timeString="2026-08-25T16:41:46.194"/>
+    </inkml:context>
+    <inkml:brush xml:id="br0">
+      <inkml:brushProperty name="width" value="0.05" units="cm"/>
+      <inkml:brushProperty name="height" value="0.05" units="cm"/>
+      <inkml:brushProperty name="color" value="#E71224"/>
+    </inkml:brush>
+  </inkml:definitions>
+  <inkml:trace contextRef="#ctx0" brushRef="#br0">407 31 24575,'0'0'0,"-1"-1"0,1 1 0,0-1 0,0 1 0,0-1 0,-1 1 0,1 0 0,0-1 0,0 1 0,-1-1 0,1 1 0,-1-1 0,1 1 0,0 0 0,-1-1 0,1 1 0,-1 0 0,1-1 0,0 1 0,-1 0 0,1 0 0,-1 0 0,1-1 0,-2 1 0,-14-5 0,11 4 0,-15-4 0,0 1 0,1 1 0,-29-1 0,-62 5 0,45 1 0,59-2 0,-1 0 0,1 0 0,0 1 0,-1 0 0,1 1 0,0-1 0,0 1 0,-11 5 0,15-6 0,1 0 0,-1 0 0,0 0 0,1 0 0,-1 1 0,1-1 0,-1 0 0,1 1 0,-1-1 0,1 1 0,0-1 0,0 1 0,0 0 0,0-1 0,0 1 0,0 0 0,0 0 0,1 0 0,-1 0 0,1 0 0,-1 0 0,1 0 0,0-1 0,0 1 0,0 0 0,0 0 0,0 0 0,0 0 0,0 0 0,1 0 0,0 4 0,2 0 0,-1-1 0,0 1 0,1-1 0,0 1 0,1-1 0,-1 0 0,1-1 0,0 1 0,0 0 0,0-1 0,1 0 0,0 0 0,5 3 0,7 5 0,1-2 0,28 14 0,206 100 0,-206-105 0,-30-12 0,1 0 0,-1 1 0,18 11 0,-33-18 0,0 0 0,0-1 0,0 1 0,0 0 0,0 0 0,-1 0 0,1-1 0,0 1 0,0 0 0,0 0 0,-1 0 0,1 0 0,-1 1 0,2 1 0,-2-3 0,0 1 0,0-1 0,0 0 0,0 1 0,0-1 0,0 1 0,-1-1 0,1 0 0,0 1 0,0-1 0,0 1 0,0-1 0,0 0 0,-1 1 0,1-1 0,0 0 0,0 1 0,-1-1 0,1 0 0,0 1 0,-1-1 0,1 0 0,0 1 0,-1-1 0,1 0 0,0 0 0,-1 1 0,-3 0 0,1 0 0,-1 1 0,1-1 0,-1-1 0,0 1 0,1 0 0,-8-1 0,-39 0 67,-97-15 0,-15-1-1566,148 16-5327</inkml:trace>
+</inkml:ink>
+</file>
+
+<file path=ppt/ink/ink7.xml><?xml version="1.0" encoding="utf-8"?>
+<inkml:ink xmlns:inkml="http://www.w3.org/2003/InkML">
+  <inkml:definitions>
+    <inkml:context xml:id="ctx0">
+      <inkml:inkSource xml:id="inkSrc0">
+        <inkml:traceFormat>
+          <inkml:channel name="X" type="integer" min="-2.14748E9" max="2.14748E9" units="cm"/>
+          <inkml:channel name="Y" type="integer" min="-2.14748E9" max="2.14748E9" units="cm"/>
+          <inkml:channel name="F" type="integer" max="32767" units="dev"/>
+        </inkml:traceFormat>
+        <inkml:channelProperties>
+          <inkml:channelProperty channel="X" name="resolution" value="1000" units="1/cm"/>
+          <inkml:channelProperty channel="Y" name="resolution" value="1000" units="1/cm"/>
+          <inkml:channelProperty channel="F" name="resolution" value="0" units="1/dev"/>
+        </inkml:channelProperties>
+      </inkml:inkSource>
+      <inkml:timestamp xml:id="ts0" timeString="2026-08-25T16:41:46.724"/>
+    </inkml:context>
+    <inkml:brush xml:id="br0">
+      <inkml:brushProperty name="width" value="0.05" units="cm"/>
+      <inkml:brushProperty name="height" value="0.05" units="cm"/>
+      <inkml:brushProperty name="color" value="#E71224"/>
+    </inkml:brush>
+  </inkml:definitions>
+  <inkml:trace contextRef="#ctx0" brushRef="#br0">0 0 24575,'1'14'0,"1"-1"0,0 1 0,1-1 0,0 0 0,9 21 0,34 68 0,-43-94 0,3 3 0,0 0 0,12 17 0,-18-28-39,0 0 0,0 1 0,0-1 0,0 0 0,0 0 0,1 0 0,-1 1 0,0-1 0,0 0 0,0 0 0,0 0 0,1 0 0,-1 1 0,0-1 0,0 0 0,0 0 0,0 0 0,1 0 0,-1 0 0,0 0 0,0 0 0,0 0 0,1 0 0,-1 1 0,0-1 0,0 0 0,1 0 0,-1 0 0,0 0 0,0 0 0,1 0 0,-1 0 0,0-1 0,1 1 0</inkml:trace>
+</inkml:ink>
+</file>
+
+<file path=ppt/ink/ink8.xml><?xml version="1.0" encoding="utf-8"?>
+<inkml:ink xmlns:inkml="http://www.w3.org/2003/InkML">
+  <inkml:definitions>
+    <inkml:context xml:id="ctx0">
+      <inkml:inkSource xml:id="inkSrc0">
+        <inkml:traceFormat>
+          <inkml:channel name="X" type="integer" min="-2.14748E9" max="2.14748E9" units="cm"/>
+          <inkml:channel name="Y" type="integer" min="-2.14748E9" max="2.14748E9" units="cm"/>
+          <inkml:channel name="F" type="integer" max="32767" units="dev"/>
+        </inkml:traceFormat>
+        <inkml:channelProperties>
+          <inkml:channelProperty channel="X" name="resolution" value="1000" units="1/cm"/>
+          <inkml:channelProperty channel="Y" name="resolution" value="1000" units="1/cm"/>
+          <inkml:channelProperty channel="F" name="resolution" value="0" units="1/dev"/>
+        </inkml:channelProperties>
+      </inkml:inkSource>
+      <inkml:timestamp xml:id="ts0" timeString="2026-08-25T16:41:46.942"/>
+    </inkml:context>
+    <inkml:brush xml:id="br0">
+      <inkml:brushProperty name="width" value="0.05" units="cm"/>
+      <inkml:brushProperty name="height" value="0.05" units="cm"/>
+      <inkml:brushProperty name="color" value="#E71224"/>
+    </inkml:brush>
+  </inkml:definitions>
+  <inkml:trace contextRef="#ctx0" brushRef="#br0">502 75 24575,'-27'-9'0,"-14"-7"0,-5 0 0,3 3 0,4 4 0,4 2 0,5 4 0,3 1 0,3 2 0,2 3 0,1 1 0,0 0 0,-2 1 0,1 1 0,-1 1 0,1-1 0,2-1 0,4-1-8191</inkml:trace>
+</inkml:ink>
+</file>
+
+<file path=ppt/ink/ink9.xml><?xml version="1.0" encoding="utf-8"?>
+<inkml:ink xmlns:inkml="http://www.w3.org/2003/InkML">
+  <inkml:definitions>
+    <inkml:context xml:id="ctx0">
+      <inkml:inkSource xml:id="inkSrc0">
+        <inkml:traceFormat>
+          <inkml:channel name="X" type="integer" min="-2.14748E9" max="2.14748E9" units="cm"/>
+          <inkml:channel name="Y" type="integer" min="-2.14748E9" max="2.14748E9" units="cm"/>
+          <inkml:channel name="F" type="integer" max="32767" units="dev"/>
+        </inkml:traceFormat>
+        <inkml:channelProperties>
+          <inkml:channelProperty channel="X" name="resolution" value="1000" units="1/cm"/>
+          <inkml:channelProperty channel="Y" name="resolution" value="1000" units="1/cm"/>
+          <inkml:channelProperty channel="F" name="resolution" value="0" units="1/dev"/>
+        </inkml:channelProperties>
+      </inkml:inkSource>
+      <inkml:timestamp xml:id="ts0" timeString="2026-08-25T16:41:47.506"/>
+    </inkml:context>
+    <inkml:brush xml:id="br0">
+      <inkml:brushProperty name="width" value="0.05" units="cm"/>
+      <inkml:brushProperty name="height" value="0.05" units="cm"/>
+      <inkml:brushProperty name="color" value="#E71224"/>
+    </inkml:brush>
+  </inkml:definitions>
+  <inkml:trace contextRef="#ctx0" brushRef="#br0">1 0 24575,'59'147'0,"-42"-108"0,-5-14 0,1-1 0,18 24 0,-27-41-1365</inkml:trace>
+</inkml:ink>
+</file>
+
 <file path=ppt/notesMasters/notesMaster1.xml><?xml version="1.0" encoding="utf-8"?>
 <p:notesMaster xmlns:a="http://schemas.openxmlformats.org/drawingml/2006/main" xmlns:r="http://schemas.openxmlformats.org/officeDocument/2006/relationships" xmlns:p="http://schemas.openxmlformats.org/presentationml/2006/main">
   <p:cSld>
@@ -2785,7 +3177,7 @@
           </a:prstGeom>
           <a:extLst>
             <a:ext uri="{C572A759-6A51-4108-AA02-DFA0A04FC94B}">
-              <ma14:wrappingTextBoxFlag xmlns:ma14="http://schemas.microsoft.com/office/mac/drawingml/2011/main" xmlns="" val="0"/>
+              <ma14:wrappingTextBoxFlag xmlns="" xmlns:ma14="http://schemas.microsoft.com/office/mac/drawingml/2011/main" val="0"/>
             </a:ext>
           </a:extLst>
         </p:spPr>
@@ -2863,7 +3255,7 @@
           </a:prstGeom>
           <a:extLst>
             <a:ext uri="{C572A759-6A51-4108-AA02-DFA0A04FC94B}">
-              <ma14:wrappingTextBoxFlag xmlns:ma14="http://schemas.microsoft.com/office/mac/drawingml/2011/main" xmlns="" val="0"/>
+              <ma14:wrappingTextBoxFlag xmlns="" xmlns:ma14="http://schemas.microsoft.com/office/mac/drawingml/2011/main" val="0"/>
             </a:ext>
           </a:extLst>
         </p:spPr>
@@ -3284,6 +3676,57 @@
           </a:p>
         </p:txBody>
       </p:sp>
+      <mc:AlternateContent xmlns:mc="http://schemas.openxmlformats.org/markup-compatibility/2006">
+        <mc:Choice xmlns:p14="http://schemas.microsoft.com/office/powerpoint/2010/main" Requires="p14">
+          <p:contentPart p14:bwMode="auto" r:id="rId3">
+            <p14:nvContentPartPr>
+              <p14:cNvPr id="4" name="Ink 3">
+                <a:extLst>
+                  <a:ext uri="{FF2B5EF4-FFF2-40B4-BE49-F238E27FC236}">
+                    <a16:creationId xmlns:a16="http://schemas.microsoft.com/office/drawing/2014/main" id="{3184E127-575C-3B30-71E4-8FE3ECBBAAD1}"/>
+                  </a:ext>
+                </a:extLst>
+              </p14:cNvPr>
+              <p14:cNvContentPartPr/>
+              <p14:nvPr/>
+            </p14:nvContentPartPr>
+            <p14:xfrm>
+              <a:off x="7714980" y="1246688"/>
+              <a:ext cx="360" cy="360"/>
+            </p14:xfrm>
+          </p:contentPart>
+        </mc:Choice>
+        <mc:Fallback>
+          <p:pic>
+            <p:nvPicPr>
+              <p:cNvPr id="4" name="Ink 3">
+                <a:extLst>
+                  <a:ext uri="{FF2B5EF4-FFF2-40B4-BE49-F238E27FC236}">
+                    <a16:creationId xmlns:a16="http://schemas.microsoft.com/office/drawing/2014/main" id="{3184E127-575C-3B30-71E4-8FE3ECBBAAD1}"/>
+                  </a:ext>
+                </a:extLst>
+              </p:cNvPr>
+              <p:cNvPicPr/>
+              <p:nvPr/>
+            </p:nvPicPr>
+            <p:blipFill>
+              <a:blip r:embed="rId4"/>
+              <a:stretch>
+                <a:fillRect/>
+              </a:stretch>
+            </p:blipFill>
+            <p:spPr>
+              <a:xfrm>
+                <a:off x="7706340" y="1238048"/>
+                <a:ext cx="18000" cy="18000"/>
+              </a:xfrm>
+              <a:prstGeom prst="rect">
+                <a:avLst/>
+              </a:prstGeom>
+            </p:spPr>
+          </p:pic>
+        </mc:Fallback>
+      </mc:AlternateContent>
     </p:spTree>
     <p:extLst>
       <p:ext uri="{BB962C8B-B14F-4D97-AF65-F5344CB8AC3E}">
@@ -3677,7 +4120,7 @@
           </a:prstGeom>
           <a:extLst>
             <a:ext uri="{C572A759-6A51-4108-AA02-DFA0A04FC94B}">
-              <ma14:wrappingTextBoxFlag xmlns:ma14="http://schemas.microsoft.com/office/mac/drawingml/2011/main" xmlns="" val="0"/>
+              <ma14:wrappingTextBoxFlag xmlns="" xmlns:ma14="http://schemas.microsoft.com/office/mac/drawingml/2011/main" val="0"/>
             </a:ext>
           </a:extLst>
         </p:spPr>
@@ -4243,7 +4686,7 @@
           </a:prstGeom>
           <a:extLst>
             <a:ext uri="{C572A759-6A51-4108-AA02-DFA0A04FC94B}">
-              <ma14:wrappingTextBoxFlag xmlns:ma14="http://schemas.microsoft.com/office/mac/drawingml/2011/main" xmlns="" val="0"/>
+              <ma14:wrappingTextBoxFlag xmlns="" xmlns:ma14="http://schemas.microsoft.com/office/mac/drawingml/2011/main" val="0"/>
             </a:ext>
           </a:extLst>
         </p:spPr>
@@ -5157,7 +5600,7 @@
           </a:prstGeom>
           <a:extLst>
             <a:ext uri="{C572A759-6A51-4108-AA02-DFA0A04FC94B}">
-              <ma14:wrappingTextBoxFlag xmlns:ma14="http://schemas.microsoft.com/office/mac/drawingml/2011/main" xmlns="" val="0"/>
+              <ma14:wrappingTextBoxFlag xmlns="" xmlns:ma14="http://schemas.microsoft.com/office/mac/drawingml/2011/main" val="0"/>
             </a:ext>
           </a:extLst>
         </p:spPr>
@@ -5723,7 +6166,7 @@
           </a:prstGeom>
           <a:extLst>
             <a:ext uri="{C572A759-6A51-4108-AA02-DFA0A04FC94B}">
-              <ma14:wrappingTextBoxFlag xmlns:ma14="http://schemas.microsoft.com/office/mac/drawingml/2011/main" xmlns="" val="0"/>
+              <ma14:wrappingTextBoxFlag xmlns="" xmlns:ma14="http://schemas.microsoft.com/office/mac/drawingml/2011/main" val="0"/>
             </a:ext>
           </a:extLst>
         </p:spPr>
@@ -6070,7 +6513,7 @@
           </a:prstGeom>
           <a:extLst>
             <a:ext uri="{C572A759-6A51-4108-AA02-DFA0A04FC94B}">
-              <ma14:wrappingTextBoxFlag xmlns:ma14="http://schemas.microsoft.com/office/mac/drawingml/2011/main" xmlns="" val="0"/>
+              <ma14:wrappingTextBoxFlag xmlns="" xmlns:ma14="http://schemas.microsoft.com/office/mac/drawingml/2011/main" val="0"/>
             </a:ext>
           </a:extLst>
         </p:spPr>
@@ -6588,7 +7031,7 @@
           </a:prstGeom>
           <a:extLst>
             <a:ext uri="{C572A759-6A51-4108-AA02-DFA0A04FC94B}">
-              <ma14:wrappingTextBoxFlag xmlns:ma14="http://schemas.microsoft.com/office/mac/drawingml/2011/main" xmlns="" val="0"/>
+              <ma14:wrappingTextBoxFlag xmlns="" xmlns:ma14="http://schemas.microsoft.com/office/mac/drawingml/2011/main" val="0"/>
             </a:ext>
           </a:extLst>
         </p:spPr>
@@ -7142,7 +7585,7 @@
           </a:prstGeom>
           <a:extLst>
             <a:ext uri="{C572A759-6A51-4108-AA02-DFA0A04FC94B}">
-              <ma14:wrappingTextBoxFlag xmlns:ma14="http://schemas.microsoft.com/office/mac/drawingml/2011/main" xmlns="" val="0"/>
+              <ma14:wrappingTextBoxFlag xmlns="" xmlns:ma14="http://schemas.microsoft.com/office/mac/drawingml/2011/main" val="0"/>
             </a:ext>
           </a:extLst>
         </p:spPr>
@@ -7622,7 +8065,7 @@
           </a:prstGeom>
           <a:extLst>
             <a:ext uri="{C572A759-6A51-4108-AA02-DFA0A04FC94B}">
-              <ma14:wrappingTextBoxFlag xmlns:ma14="http://schemas.microsoft.com/office/mac/drawingml/2011/main" xmlns="" val="0"/>
+              <ma14:wrappingTextBoxFlag xmlns="" xmlns:ma14="http://schemas.microsoft.com/office/mac/drawingml/2011/main" val="0"/>
             </a:ext>
           </a:extLst>
         </p:spPr>
@@ -8295,7 +8738,7 @@
           </a:prstGeom>
           <a:extLst>
             <a:ext uri="{C572A759-6A51-4108-AA02-DFA0A04FC94B}">
-              <ma14:wrappingTextBoxFlag xmlns:ma14="http://schemas.microsoft.com/office/mac/drawingml/2011/main" xmlns="" val="0"/>
+              <ma14:wrappingTextBoxFlag xmlns="" xmlns:ma14="http://schemas.microsoft.com/office/mac/drawingml/2011/main" val="0"/>
             </a:ext>
           </a:extLst>
         </p:spPr>
@@ -8891,7 +9334,7 @@
           </a:prstGeom>
           <a:extLst>
             <a:ext uri="{C572A759-6A51-4108-AA02-DFA0A04FC94B}">
-              <ma14:wrappingTextBoxFlag xmlns:ma14="http://schemas.microsoft.com/office/mac/drawingml/2011/main" xmlns="" val="0"/>
+              <ma14:wrappingTextBoxFlag xmlns="" xmlns:ma14="http://schemas.microsoft.com/office/mac/drawingml/2011/main" val="0"/>
             </a:ext>
           </a:extLst>
         </p:spPr>
@@ -9864,7 +10307,7 @@
           </a:prstGeom>
           <a:extLst>
             <a:ext uri="{C572A759-6A51-4108-AA02-DFA0A04FC94B}">
-              <ma14:wrappingTextBoxFlag xmlns:ma14="http://schemas.microsoft.com/office/mac/drawingml/2011/main" xmlns="" val="0"/>
+              <ma14:wrappingTextBoxFlag xmlns="" xmlns:ma14="http://schemas.microsoft.com/office/mac/drawingml/2011/main" val="0"/>
             </a:ext>
           </a:extLst>
         </p:spPr>
@@ -9892,6 +10335,690 @@
           </a:p>
         </p:txBody>
       </p:sp>
+      <mc:AlternateContent xmlns:mc="http://schemas.openxmlformats.org/markup-compatibility/2006">
+        <mc:Choice xmlns:p14="http://schemas.microsoft.com/office/powerpoint/2010/main" Requires="p14">
+          <p:contentPart p14:bwMode="auto" r:id="rId3">
+            <p14:nvContentPartPr>
+              <p14:cNvPr id="28" name="Ink 27">
+                <a:extLst>
+                  <a:ext uri="{FF2B5EF4-FFF2-40B4-BE49-F238E27FC236}">
+                    <a16:creationId xmlns:a16="http://schemas.microsoft.com/office/drawing/2014/main" id="{8C4FA8E9-BEEB-9715-D3DA-52F4501CDA77}"/>
+                  </a:ext>
+                </a:extLst>
+              </p14:cNvPr>
+              <p14:cNvContentPartPr/>
+              <p14:nvPr/>
+            </p14:nvContentPartPr>
+            <p14:xfrm>
+              <a:off x="1439100" y="5257088"/>
+              <a:ext cx="518040" cy="21600"/>
+            </p14:xfrm>
+          </p:contentPart>
+        </mc:Choice>
+        <mc:Fallback>
+          <p:pic>
+            <p:nvPicPr>
+              <p:cNvPr id="28" name="Ink 27">
+                <a:extLst>
+                  <a:ext uri="{FF2B5EF4-FFF2-40B4-BE49-F238E27FC236}">
+                    <a16:creationId xmlns:a16="http://schemas.microsoft.com/office/drawing/2014/main" id="{8C4FA8E9-BEEB-9715-D3DA-52F4501CDA77}"/>
+                  </a:ext>
+                </a:extLst>
+              </p:cNvPr>
+              <p:cNvPicPr/>
+              <p:nvPr/>
+            </p:nvPicPr>
+            <p:blipFill>
+              <a:blip r:embed="rId4"/>
+              <a:stretch>
+                <a:fillRect/>
+              </a:stretch>
+            </p:blipFill>
+            <p:spPr>
+              <a:xfrm>
+                <a:off x="1430100" y="5248448"/>
+                <a:ext cx="535680" cy="39240"/>
+              </a:xfrm>
+              <a:prstGeom prst="rect">
+                <a:avLst/>
+              </a:prstGeom>
+            </p:spPr>
+          </p:pic>
+        </mc:Fallback>
+      </mc:AlternateContent>
+      <mc:AlternateContent xmlns:mc="http://schemas.openxmlformats.org/markup-compatibility/2006">
+        <mc:Choice xmlns:p14="http://schemas.microsoft.com/office/powerpoint/2010/main" Requires="p14">
+          <p:contentPart p14:bwMode="auto" r:id="rId5">
+            <p14:nvContentPartPr>
+              <p14:cNvPr id="29" name="Ink 28">
+                <a:extLst>
+                  <a:ext uri="{FF2B5EF4-FFF2-40B4-BE49-F238E27FC236}">
+                    <a16:creationId xmlns:a16="http://schemas.microsoft.com/office/drawing/2014/main" id="{08BA98BA-48D1-7A06-B77D-F05883484ABF}"/>
+                  </a:ext>
+                </a:extLst>
+              </p14:cNvPr>
+              <p14:cNvContentPartPr/>
+              <p14:nvPr/>
+            </p14:nvContentPartPr>
+            <p14:xfrm>
+              <a:off x="5795460" y="5239808"/>
+              <a:ext cx="619560" cy="23040"/>
+            </p14:xfrm>
+          </p:contentPart>
+        </mc:Choice>
+        <mc:Fallback>
+          <p:pic>
+            <p:nvPicPr>
+              <p:cNvPr id="29" name="Ink 28">
+                <a:extLst>
+                  <a:ext uri="{FF2B5EF4-FFF2-40B4-BE49-F238E27FC236}">
+                    <a16:creationId xmlns:a16="http://schemas.microsoft.com/office/drawing/2014/main" id="{08BA98BA-48D1-7A06-B77D-F05883484ABF}"/>
+                  </a:ext>
+                </a:extLst>
+              </p:cNvPr>
+              <p:cNvPicPr/>
+              <p:nvPr/>
+            </p:nvPicPr>
+            <p:blipFill>
+              <a:blip r:embed="rId6"/>
+              <a:stretch>
+                <a:fillRect/>
+              </a:stretch>
+            </p:blipFill>
+            <p:spPr>
+              <a:xfrm>
+                <a:off x="5786460" y="5231168"/>
+                <a:ext cx="637200" cy="40680"/>
+              </a:xfrm>
+              <a:prstGeom prst="rect">
+                <a:avLst/>
+              </a:prstGeom>
+            </p:spPr>
+          </p:pic>
+        </mc:Fallback>
+      </mc:AlternateContent>
+      <mc:AlternateContent xmlns:mc="http://schemas.openxmlformats.org/markup-compatibility/2006">
+        <mc:Choice xmlns:p14="http://schemas.microsoft.com/office/powerpoint/2010/main" Requires="p14">
+          <p:contentPart p14:bwMode="auto" r:id="rId7">
+            <p14:nvContentPartPr>
+              <p14:cNvPr id="30" name="Ink 29">
+                <a:extLst>
+                  <a:ext uri="{FF2B5EF4-FFF2-40B4-BE49-F238E27FC236}">
+                    <a16:creationId xmlns:a16="http://schemas.microsoft.com/office/drawing/2014/main" id="{7A20F6CC-856B-0960-14A2-6863C41C3D6E}"/>
+                  </a:ext>
+                </a:extLst>
+              </p14:cNvPr>
+              <p14:cNvContentPartPr/>
+              <p14:nvPr/>
+            </p14:nvContentPartPr>
+            <p14:xfrm>
+              <a:off x="8073900" y="5241968"/>
+              <a:ext cx="502200" cy="21240"/>
+            </p14:xfrm>
+          </p:contentPart>
+        </mc:Choice>
+        <mc:Fallback>
+          <p:pic>
+            <p:nvPicPr>
+              <p:cNvPr id="30" name="Ink 29">
+                <a:extLst>
+                  <a:ext uri="{FF2B5EF4-FFF2-40B4-BE49-F238E27FC236}">
+                    <a16:creationId xmlns:a16="http://schemas.microsoft.com/office/drawing/2014/main" id="{7A20F6CC-856B-0960-14A2-6863C41C3D6E}"/>
+                  </a:ext>
+                </a:extLst>
+              </p:cNvPr>
+              <p:cNvPicPr/>
+              <p:nvPr/>
+            </p:nvPicPr>
+            <p:blipFill>
+              <a:blip r:embed="rId8"/>
+              <a:stretch>
+                <a:fillRect/>
+              </a:stretch>
+            </p:blipFill>
+            <p:spPr>
+              <a:xfrm>
+                <a:off x="8065260" y="5233328"/>
+                <a:ext cx="519840" cy="38880"/>
+              </a:xfrm>
+              <a:prstGeom prst="rect">
+                <a:avLst/>
+              </a:prstGeom>
+            </p:spPr>
+          </p:pic>
+        </mc:Fallback>
+      </mc:AlternateContent>
+      <mc:AlternateContent xmlns:mc="http://schemas.openxmlformats.org/markup-compatibility/2006">
+        <mc:Choice xmlns:p14="http://schemas.microsoft.com/office/powerpoint/2010/main" Requires="p14">
+          <p:contentPart p14:bwMode="auto" r:id="rId9">
+            <p14:nvContentPartPr>
+              <p14:cNvPr id="31" name="Ink 30">
+                <a:extLst>
+                  <a:ext uri="{FF2B5EF4-FFF2-40B4-BE49-F238E27FC236}">
+                    <a16:creationId xmlns:a16="http://schemas.microsoft.com/office/drawing/2014/main" id="{69AC49FF-9E56-D384-C4B7-D87C4C5D11F2}"/>
+                  </a:ext>
+                </a:extLst>
+              </p14:cNvPr>
+              <p14:cNvContentPartPr/>
+              <p14:nvPr/>
+            </p14:nvContentPartPr>
+            <p14:xfrm>
+              <a:off x="10117260" y="5241968"/>
+              <a:ext cx="725040" cy="21600"/>
+            </p14:xfrm>
+          </p:contentPart>
+        </mc:Choice>
+        <mc:Fallback>
+          <p:pic>
+            <p:nvPicPr>
+              <p:cNvPr id="31" name="Ink 30">
+                <a:extLst>
+                  <a:ext uri="{FF2B5EF4-FFF2-40B4-BE49-F238E27FC236}">
+                    <a16:creationId xmlns:a16="http://schemas.microsoft.com/office/drawing/2014/main" id="{69AC49FF-9E56-D384-C4B7-D87C4C5D11F2}"/>
+                  </a:ext>
+                </a:extLst>
+              </p:cNvPr>
+              <p:cNvPicPr/>
+              <p:nvPr/>
+            </p:nvPicPr>
+            <p:blipFill>
+              <a:blip r:embed="rId10"/>
+              <a:stretch>
+                <a:fillRect/>
+              </a:stretch>
+            </p:blipFill>
+            <p:spPr>
+              <a:xfrm>
+                <a:off x="10108260" y="5233328"/>
+                <a:ext cx="742680" cy="39240"/>
+              </a:xfrm>
+              <a:prstGeom prst="rect">
+                <a:avLst/>
+              </a:prstGeom>
+            </p:spPr>
+          </p:pic>
+        </mc:Fallback>
+      </mc:AlternateContent>
+      <p:grpSp>
+        <p:nvGrpSpPr>
+          <p:cNvPr id="40" name="Group 39">
+            <a:extLst>
+              <a:ext uri="{FF2B5EF4-FFF2-40B4-BE49-F238E27FC236}">
+                <a16:creationId xmlns:a16="http://schemas.microsoft.com/office/drawing/2014/main" id="{6289B870-86BD-A3A1-10C1-6B16795E320F}"/>
+              </a:ext>
+            </a:extLst>
+          </p:cNvPr>
+          <p:cNvGrpSpPr/>
+          <p:nvPr/>
+        </p:nvGrpSpPr>
+        <p:grpSpPr>
+          <a:xfrm>
+            <a:off x="9818460" y="5568848"/>
+            <a:ext cx="759600" cy="167760"/>
+            <a:chOff x="9818460" y="5568848"/>
+            <a:chExt cx="759600" cy="167760"/>
+          </a:xfrm>
+        </p:grpSpPr>
+        <mc:AlternateContent xmlns:mc="http://schemas.openxmlformats.org/markup-compatibility/2006">
+          <mc:Choice xmlns:p14="http://schemas.microsoft.com/office/powerpoint/2010/main" Requires="p14">
+            <p:contentPart p14:bwMode="auto" r:id="rId11">
+              <p14:nvContentPartPr>
+                <p14:cNvPr id="32" name="Ink 31">
+                  <a:extLst>
+                    <a:ext uri="{FF2B5EF4-FFF2-40B4-BE49-F238E27FC236}">
+                      <a16:creationId xmlns:a16="http://schemas.microsoft.com/office/drawing/2014/main" id="{3EB107BC-B082-CF94-2F36-6908E3DA8798}"/>
+                    </a:ext>
+                  </a:extLst>
+                </p14:cNvPr>
+                <p14:cNvContentPartPr/>
+                <p14:nvPr/>
+              </p14:nvContentPartPr>
+              <p14:xfrm>
+                <a:off x="9818460" y="5589368"/>
+                <a:ext cx="192240" cy="147240"/>
+              </p14:xfrm>
+            </p:contentPart>
+          </mc:Choice>
+          <mc:Fallback>
+            <p:pic>
+              <p:nvPicPr>
+                <p:cNvPr id="32" name="Ink 31">
+                  <a:extLst>
+                    <a:ext uri="{FF2B5EF4-FFF2-40B4-BE49-F238E27FC236}">
+                      <a16:creationId xmlns:a16="http://schemas.microsoft.com/office/drawing/2014/main" id="{3EB107BC-B082-CF94-2F36-6908E3DA8798}"/>
+                    </a:ext>
+                  </a:extLst>
+                </p:cNvPr>
+                <p:cNvPicPr/>
+                <p:nvPr/>
+              </p:nvPicPr>
+              <p:blipFill>
+                <a:blip r:embed="rId12"/>
+                <a:stretch>
+                  <a:fillRect/>
+                </a:stretch>
+              </p:blipFill>
+              <p:spPr>
+                <a:xfrm>
+                  <a:off x="9809820" y="5580368"/>
+                  <a:ext cx="209880" cy="164880"/>
+                </a:xfrm>
+                <a:prstGeom prst="rect">
+                  <a:avLst/>
+                </a:prstGeom>
+              </p:spPr>
+            </p:pic>
+          </mc:Fallback>
+        </mc:AlternateContent>
+        <mc:AlternateContent xmlns:mc="http://schemas.openxmlformats.org/markup-compatibility/2006">
+          <mc:Choice xmlns:p14="http://schemas.microsoft.com/office/powerpoint/2010/main" Requires="p14">
+            <p:contentPart p14:bwMode="auto" r:id="rId13">
+              <p14:nvContentPartPr>
+                <p14:cNvPr id="33" name="Ink 32">
+                  <a:extLst>
+                    <a:ext uri="{FF2B5EF4-FFF2-40B4-BE49-F238E27FC236}">
+                      <a16:creationId xmlns:a16="http://schemas.microsoft.com/office/drawing/2014/main" id="{F18744A7-F1E7-7D45-5169-3A3CDB6DED34}"/>
+                    </a:ext>
+                  </a:extLst>
+                </p14:cNvPr>
+                <p14:cNvContentPartPr/>
+                <p14:nvPr/>
+              </p14:nvContentPartPr>
+              <p14:xfrm>
+                <a:off x="10115460" y="5631848"/>
+                <a:ext cx="39240" cy="95760"/>
+              </p14:xfrm>
+            </p:contentPart>
+          </mc:Choice>
+          <mc:Fallback>
+            <p:pic>
+              <p:nvPicPr>
+                <p:cNvPr id="33" name="Ink 32">
+                  <a:extLst>
+                    <a:ext uri="{FF2B5EF4-FFF2-40B4-BE49-F238E27FC236}">
+                      <a16:creationId xmlns:a16="http://schemas.microsoft.com/office/drawing/2014/main" id="{F18744A7-F1E7-7D45-5169-3A3CDB6DED34}"/>
+                    </a:ext>
+                  </a:extLst>
+                </p:cNvPr>
+                <p:cNvPicPr/>
+                <p:nvPr/>
+              </p:nvPicPr>
+              <p:blipFill>
+                <a:blip r:embed="rId14"/>
+                <a:stretch>
+                  <a:fillRect/>
+                </a:stretch>
+              </p:blipFill>
+              <p:spPr>
+                <a:xfrm>
+                  <a:off x="10106460" y="5622848"/>
+                  <a:ext cx="56880" cy="113400"/>
+                </a:xfrm>
+                <a:prstGeom prst="rect">
+                  <a:avLst/>
+                </a:prstGeom>
+              </p:spPr>
+            </p:pic>
+          </mc:Fallback>
+        </mc:AlternateContent>
+        <mc:AlternateContent xmlns:mc="http://schemas.openxmlformats.org/markup-compatibility/2006">
+          <mc:Choice xmlns:p14="http://schemas.microsoft.com/office/powerpoint/2010/main" Requires="p14">
+            <p:contentPart p14:bwMode="auto" r:id="rId15">
+              <p14:nvContentPartPr>
+                <p14:cNvPr id="34" name="Ink 33">
+                  <a:extLst>
+                    <a:ext uri="{FF2B5EF4-FFF2-40B4-BE49-F238E27FC236}">
+                      <a16:creationId xmlns:a16="http://schemas.microsoft.com/office/drawing/2014/main" id="{486E2F7E-492A-67CE-3AD7-381FEE28B462}"/>
+                    </a:ext>
+                  </a:extLst>
+                </p14:cNvPr>
+                <p14:cNvContentPartPr/>
+                <p14:nvPr/>
+              </p14:nvContentPartPr>
+              <p14:xfrm>
+                <a:off x="10012860" y="5583968"/>
+                <a:ext cx="181080" cy="27360"/>
+              </p14:xfrm>
+            </p:contentPart>
+          </mc:Choice>
+          <mc:Fallback>
+            <p:pic>
+              <p:nvPicPr>
+                <p:cNvPr id="34" name="Ink 33">
+                  <a:extLst>
+                    <a:ext uri="{FF2B5EF4-FFF2-40B4-BE49-F238E27FC236}">
+                      <a16:creationId xmlns:a16="http://schemas.microsoft.com/office/drawing/2014/main" id="{486E2F7E-492A-67CE-3AD7-381FEE28B462}"/>
+                    </a:ext>
+                  </a:extLst>
+                </p:cNvPr>
+                <p:cNvPicPr/>
+                <p:nvPr/>
+              </p:nvPicPr>
+              <p:blipFill>
+                <a:blip r:embed="rId16"/>
+                <a:stretch>
+                  <a:fillRect/>
+                </a:stretch>
+              </p:blipFill>
+              <p:spPr>
+                <a:xfrm>
+                  <a:off x="10003860" y="5574968"/>
+                  <a:ext cx="198720" cy="45000"/>
+                </a:xfrm>
+                <a:prstGeom prst="rect">
+                  <a:avLst/>
+                </a:prstGeom>
+              </p:spPr>
+            </p:pic>
+          </mc:Fallback>
+        </mc:AlternateContent>
+        <mc:AlternateContent xmlns:mc="http://schemas.openxmlformats.org/markup-compatibility/2006">
+          <mc:Choice xmlns:p14="http://schemas.microsoft.com/office/powerpoint/2010/main" Requires="p14">
+            <p:contentPart p14:bwMode="auto" r:id="rId17">
+              <p14:nvContentPartPr>
+                <p14:cNvPr id="35" name="Ink 34">
+                  <a:extLst>
+                    <a:ext uri="{FF2B5EF4-FFF2-40B4-BE49-F238E27FC236}">
+                      <a16:creationId xmlns:a16="http://schemas.microsoft.com/office/drawing/2014/main" id="{F0971A8E-9DFA-22F6-1B21-E0A6D64B3659}"/>
+                    </a:ext>
+                  </a:extLst>
+                </p14:cNvPr>
+                <p14:cNvContentPartPr/>
+                <p14:nvPr/>
+              </p14:nvContentPartPr>
+              <p14:xfrm>
+                <a:off x="10291860" y="5631848"/>
+                <a:ext cx="49320" cy="104760"/>
+              </p14:xfrm>
+            </p:contentPart>
+          </mc:Choice>
+          <mc:Fallback>
+            <p:pic>
+              <p:nvPicPr>
+                <p:cNvPr id="35" name="Ink 34">
+                  <a:extLst>
+                    <a:ext uri="{FF2B5EF4-FFF2-40B4-BE49-F238E27FC236}">
+                      <a16:creationId xmlns:a16="http://schemas.microsoft.com/office/drawing/2014/main" id="{F0971A8E-9DFA-22F6-1B21-E0A6D64B3659}"/>
+                    </a:ext>
+                  </a:extLst>
+                </p:cNvPr>
+                <p:cNvPicPr/>
+                <p:nvPr/>
+              </p:nvPicPr>
+              <p:blipFill>
+                <a:blip r:embed="rId18"/>
+                <a:stretch>
+                  <a:fillRect/>
+                </a:stretch>
+              </p:blipFill>
+              <p:spPr>
+                <a:xfrm>
+                  <a:off x="10283220" y="5622848"/>
+                  <a:ext cx="66960" cy="122400"/>
+                </a:xfrm>
+                <a:prstGeom prst="rect">
+                  <a:avLst/>
+                </a:prstGeom>
+              </p:spPr>
+            </p:pic>
+          </mc:Fallback>
+        </mc:AlternateContent>
+        <mc:AlternateContent xmlns:mc="http://schemas.openxmlformats.org/markup-compatibility/2006">
+          <mc:Choice xmlns:p14="http://schemas.microsoft.com/office/powerpoint/2010/main" Requires="p14">
+            <p:contentPart p14:bwMode="auto" r:id="rId19">
+              <p14:nvContentPartPr>
+                <p14:cNvPr id="36" name="Ink 35">
+                  <a:extLst>
+                    <a:ext uri="{FF2B5EF4-FFF2-40B4-BE49-F238E27FC236}">
+                      <a16:creationId xmlns:a16="http://schemas.microsoft.com/office/drawing/2014/main" id="{4E017A54-B957-9F34-01CB-3A8E30D88F42}"/>
+                    </a:ext>
+                  </a:extLst>
+                </p14:cNvPr>
+                <p14:cNvContentPartPr/>
+                <p14:nvPr/>
+              </p14:nvContentPartPr>
+              <p14:xfrm>
+                <a:off x="10276380" y="5568848"/>
+                <a:ext cx="93960" cy="42480"/>
+              </p14:xfrm>
+            </p:contentPart>
+          </mc:Choice>
+          <mc:Fallback>
+            <p:pic>
+              <p:nvPicPr>
+                <p:cNvPr id="36" name="Ink 35">
+                  <a:extLst>
+                    <a:ext uri="{FF2B5EF4-FFF2-40B4-BE49-F238E27FC236}">
+                      <a16:creationId xmlns:a16="http://schemas.microsoft.com/office/drawing/2014/main" id="{4E017A54-B957-9F34-01CB-3A8E30D88F42}"/>
+                    </a:ext>
+                  </a:extLst>
+                </p:cNvPr>
+                <p:cNvPicPr/>
+                <p:nvPr/>
+              </p:nvPicPr>
+              <p:blipFill>
+                <a:blip r:embed="rId20"/>
+                <a:stretch>
+                  <a:fillRect/>
+                </a:stretch>
+              </p:blipFill>
+              <p:spPr>
+                <a:xfrm>
+                  <a:off x="10267740" y="5559848"/>
+                  <a:ext cx="111600" cy="60120"/>
+                </a:xfrm>
+                <a:prstGeom prst="rect">
+                  <a:avLst/>
+                </a:prstGeom>
+              </p:spPr>
+            </p:pic>
+          </mc:Fallback>
+        </mc:AlternateContent>
+        <mc:AlternateContent xmlns:mc="http://schemas.openxmlformats.org/markup-compatibility/2006">
+          <mc:Choice xmlns:p14="http://schemas.microsoft.com/office/powerpoint/2010/main" Requires="p14">
+            <p:contentPart p14:bwMode="auto" r:id="rId21">
+              <p14:nvContentPartPr>
+                <p14:cNvPr id="37" name="Ink 36">
+                  <a:extLst>
+                    <a:ext uri="{FF2B5EF4-FFF2-40B4-BE49-F238E27FC236}">
+                      <a16:creationId xmlns:a16="http://schemas.microsoft.com/office/drawing/2014/main" id="{9927A686-32E9-4BEF-1A2E-9803ED4BC3AB}"/>
+                    </a:ext>
+                  </a:extLst>
+                </p14:cNvPr>
+                <p14:cNvContentPartPr/>
+                <p14:nvPr/>
+              </p14:nvContentPartPr>
+              <p14:xfrm>
+                <a:off x="10286820" y="5655248"/>
+                <a:ext cx="86040" cy="7920"/>
+              </p14:xfrm>
+            </p:contentPart>
+          </mc:Choice>
+          <mc:Fallback>
+            <p:pic>
+              <p:nvPicPr>
+                <p:cNvPr id="37" name="Ink 36">
+                  <a:extLst>
+                    <a:ext uri="{FF2B5EF4-FFF2-40B4-BE49-F238E27FC236}">
+                      <a16:creationId xmlns:a16="http://schemas.microsoft.com/office/drawing/2014/main" id="{9927A686-32E9-4BEF-1A2E-9803ED4BC3AB}"/>
+                    </a:ext>
+                  </a:extLst>
+                </p:cNvPr>
+                <p:cNvPicPr/>
+                <p:nvPr/>
+              </p:nvPicPr>
+              <p:blipFill>
+                <a:blip r:embed="rId22"/>
+                <a:stretch>
+                  <a:fillRect/>
+                </a:stretch>
+              </p:blipFill>
+              <p:spPr>
+                <a:xfrm>
+                  <a:off x="10277820" y="5646608"/>
+                  <a:ext cx="103680" cy="25560"/>
+                </a:xfrm>
+                <a:prstGeom prst="rect">
+                  <a:avLst/>
+                </a:prstGeom>
+              </p:spPr>
+            </p:pic>
+          </mc:Fallback>
+        </mc:AlternateContent>
+        <mc:AlternateContent xmlns:mc="http://schemas.openxmlformats.org/markup-compatibility/2006">
+          <mc:Choice xmlns:p14="http://schemas.microsoft.com/office/powerpoint/2010/main" Requires="p14">
+            <p:contentPart p14:bwMode="auto" r:id="rId23">
+              <p14:nvContentPartPr>
+                <p14:cNvPr id="38" name="Ink 37">
+                  <a:extLst>
+                    <a:ext uri="{FF2B5EF4-FFF2-40B4-BE49-F238E27FC236}">
+                      <a16:creationId xmlns:a16="http://schemas.microsoft.com/office/drawing/2014/main" id="{78BE1F80-F1A8-1E5E-F687-E290C698C671}"/>
+                    </a:ext>
+                  </a:extLst>
+                </p14:cNvPr>
+                <p14:cNvContentPartPr/>
+                <p14:nvPr/>
+              </p14:nvContentPartPr>
+              <p14:xfrm>
+                <a:off x="10510380" y="5610968"/>
+                <a:ext cx="50760" cy="115920"/>
+              </p14:xfrm>
+            </p:contentPart>
+          </mc:Choice>
+          <mc:Fallback>
+            <p:pic>
+              <p:nvPicPr>
+                <p:cNvPr id="38" name="Ink 37">
+                  <a:extLst>
+                    <a:ext uri="{FF2B5EF4-FFF2-40B4-BE49-F238E27FC236}">
+                      <a16:creationId xmlns:a16="http://schemas.microsoft.com/office/drawing/2014/main" id="{78BE1F80-F1A8-1E5E-F687-E290C698C671}"/>
+                    </a:ext>
+                  </a:extLst>
+                </p:cNvPr>
+                <p:cNvPicPr/>
+                <p:nvPr/>
+              </p:nvPicPr>
+              <p:blipFill>
+                <a:blip r:embed="rId24"/>
+                <a:stretch>
+                  <a:fillRect/>
+                </a:stretch>
+              </p:blipFill>
+              <p:spPr>
+                <a:xfrm>
+                  <a:off x="10501380" y="5601968"/>
+                  <a:ext cx="68400" cy="133560"/>
+                </a:xfrm>
+                <a:prstGeom prst="rect">
+                  <a:avLst/>
+                </a:prstGeom>
+              </p:spPr>
+            </p:pic>
+          </mc:Fallback>
+        </mc:AlternateContent>
+        <mc:AlternateContent xmlns:mc="http://schemas.openxmlformats.org/markup-compatibility/2006">
+          <mc:Choice xmlns:p14="http://schemas.microsoft.com/office/powerpoint/2010/main" Requires="p14">
+            <p:contentPart p14:bwMode="auto" r:id="rId25">
+              <p14:nvContentPartPr>
+                <p14:cNvPr id="39" name="Ink 38">
+                  <a:extLst>
+                    <a:ext uri="{FF2B5EF4-FFF2-40B4-BE49-F238E27FC236}">
+                      <a16:creationId xmlns:a16="http://schemas.microsoft.com/office/drawing/2014/main" id="{7DFA75E9-A1D3-9344-3E41-A4F4C5C4D974}"/>
+                    </a:ext>
+                  </a:extLst>
+                </p14:cNvPr>
+                <p14:cNvContentPartPr/>
+                <p14:nvPr/>
+              </p14:nvContentPartPr>
+              <p14:xfrm>
+                <a:off x="10439460" y="5577488"/>
+                <a:ext cx="138600" cy="7920"/>
+              </p14:xfrm>
+            </p:contentPart>
+          </mc:Choice>
+          <mc:Fallback>
+            <p:pic>
+              <p:nvPicPr>
+                <p:cNvPr id="39" name="Ink 38">
+                  <a:extLst>
+                    <a:ext uri="{FF2B5EF4-FFF2-40B4-BE49-F238E27FC236}">
+                      <a16:creationId xmlns:a16="http://schemas.microsoft.com/office/drawing/2014/main" id="{7DFA75E9-A1D3-9344-3E41-A4F4C5C4D974}"/>
+                    </a:ext>
+                  </a:extLst>
+                </p:cNvPr>
+                <p:cNvPicPr/>
+                <p:nvPr/>
+              </p:nvPicPr>
+              <p:blipFill>
+                <a:blip r:embed="rId26"/>
+                <a:stretch>
+                  <a:fillRect/>
+                </a:stretch>
+              </p:blipFill>
+              <p:spPr>
+                <a:xfrm>
+                  <a:off x="10430820" y="5568488"/>
+                  <a:ext cx="156240" cy="25560"/>
+                </a:xfrm>
+                <a:prstGeom prst="rect">
+                  <a:avLst/>
+                </a:prstGeom>
+              </p:spPr>
+            </p:pic>
+          </mc:Fallback>
+        </mc:AlternateContent>
+      </p:grpSp>
+      <mc:AlternateContent xmlns:mc="http://schemas.openxmlformats.org/markup-compatibility/2006">
+        <mc:Choice xmlns:p14="http://schemas.microsoft.com/office/powerpoint/2010/main" Requires="p14">
+          <p:contentPart p14:bwMode="auto" r:id="rId27">
+            <p14:nvContentPartPr>
+              <p14:cNvPr id="41" name="Ink 40">
+                <a:extLst>
+                  <a:ext uri="{FF2B5EF4-FFF2-40B4-BE49-F238E27FC236}">
+                    <a16:creationId xmlns:a16="http://schemas.microsoft.com/office/drawing/2014/main" id="{2ADF71E8-0DE8-5E2A-5B06-50EB613B0726}"/>
+                  </a:ext>
+                </a:extLst>
+              </p14:cNvPr>
+              <p14:cNvContentPartPr/>
+              <p14:nvPr/>
+            </p14:nvContentPartPr>
+            <p14:xfrm>
+              <a:off x="7252740" y="5236928"/>
+              <a:ext cx="360" cy="360"/>
+            </p14:xfrm>
+          </p:contentPart>
+        </mc:Choice>
+        <mc:Fallback>
+          <p:pic>
+            <p:nvPicPr>
+              <p:cNvPr id="41" name="Ink 40">
+                <a:extLst>
+                  <a:ext uri="{FF2B5EF4-FFF2-40B4-BE49-F238E27FC236}">
+                    <a16:creationId xmlns:a16="http://schemas.microsoft.com/office/drawing/2014/main" id="{2ADF71E8-0DE8-5E2A-5B06-50EB613B0726}"/>
+                  </a:ext>
+                </a:extLst>
+              </p:cNvPr>
+              <p:cNvPicPr/>
+              <p:nvPr/>
+            </p:nvPicPr>
+            <p:blipFill>
+              <a:blip r:embed="rId28"/>
+              <a:stretch>
+                <a:fillRect/>
+              </a:stretch>
+            </p:blipFill>
+            <p:spPr>
+              <a:xfrm>
+                <a:off x="7243740" y="5227928"/>
+                <a:ext cx="18000" cy="18000"/>
+              </a:xfrm>
+              <a:prstGeom prst="rect">
+                <a:avLst/>
+              </a:prstGeom>
+            </p:spPr>
+          </p:pic>
+        </mc:Fallback>
+      </mc:AlternateContent>
     </p:spTree>
   </p:cSld>
   <p:clrMapOvr>
@@ -10819,7 +11946,7 @@
           </a:prstGeom>
           <a:extLst>
             <a:ext uri="{C572A759-6A51-4108-AA02-DFA0A04FC94B}">
-              <ma14:wrappingTextBoxFlag xmlns:ma14="http://schemas.microsoft.com/office/mac/drawingml/2011/main" xmlns="" val="0"/>
+              <ma14:wrappingTextBoxFlag xmlns="" xmlns:ma14="http://schemas.microsoft.com/office/mac/drawingml/2011/main" val="0"/>
             </a:ext>
           </a:extLst>
         </p:spPr>
@@ -11361,7 +12488,7 @@
           </a:prstGeom>
           <a:extLst>
             <a:ext uri="{C572A759-6A51-4108-AA02-DFA0A04FC94B}">
-              <ma14:wrappingTextBoxFlag xmlns:ma14="http://schemas.microsoft.com/office/mac/drawingml/2011/main" xmlns="" val="0"/>
+              <ma14:wrappingTextBoxFlag xmlns="" xmlns:ma14="http://schemas.microsoft.com/office/mac/drawingml/2011/main" val="0"/>
             </a:ext>
           </a:extLst>
         </p:spPr>
@@ -11935,7 +13062,7 @@
           </a:prstGeom>
           <a:extLst>
             <a:ext uri="{C572A759-6A51-4108-AA02-DFA0A04FC94B}">
-              <ma14:wrappingTextBoxFlag xmlns:ma14="http://schemas.microsoft.com/office/mac/drawingml/2011/main" xmlns="" val="0"/>
+              <ma14:wrappingTextBoxFlag xmlns="" xmlns:ma14="http://schemas.microsoft.com/office/mac/drawingml/2011/main" val="0"/>
             </a:ext>
           </a:extLst>
         </p:spPr>
@@ -12998,7 +14125,7 @@
           </a:prstGeom>
           <a:extLst>
             <a:ext uri="{C572A759-6A51-4108-AA02-DFA0A04FC94B}">
-              <ma14:wrappingTextBoxFlag xmlns:ma14="http://schemas.microsoft.com/office/mac/drawingml/2011/main" xmlns="" val="0"/>
+              <ma14:wrappingTextBoxFlag xmlns="" xmlns:ma14="http://schemas.microsoft.com/office/mac/drawingml/2011/main" val="0"/>
             </a:ext>
           </a:extLst>
         </p:spPr>
@@ -13401,7 +14528,7 @@
           </a:prstGeom>
           <a:extLst>
             <a:ext uri="{C572A759-6A51-4108-AA02-DFA0A04FC94B}">
-              <ma14:wrappingTextBoxFlag xmlns:ma14="http://schemas.microsoft.com/office/mac/drawingml/2011/main" xmlns="" val="0"/>
+              <ma14:wrappingTextBoxFlag xmlns="" xmlns:ma14="http://schemas.microsoft.com/office/mac/drawingml/2011/main" val="0"/>
             </a:ext>
           </a:extLst>
         </p:spPr>
@@ -13826,7 +14953,7 @@
           </a:prstGeom>
           <a:extLst>
             <a:ext uri="{C572A759-6A51-4108-AA02-DFA0A04FC94B}">
-              <ma14:wrappingTextBoxFlag xmlns:ma14="http://schemas.microsoft.com/office/mac/drawingml/2011/main" xmlns="" val="0"/>
+              <ma14:wrappingTextBoxFlag xmlns="" xmlns:ma14="http://schemas.microsoft.com/office/mac/drawingml/2011/main" val="0"/>
             </a:ext>
           </a:extLst>
         </p:spPr>
@@ -14272,7 +15399,7 @@
           </a:prstGeom>
           <a:extLst>
             <a:ext uri="{C572A759-6A51-4108-AA02-DFA0A04FC94B}">
-              <ma14:wrappingTextBoxFlag xmlns:ma14="http://schemas.microsoft.com/office/mac/drawingml/2011/main" xmlns="" val="0"/>
+              <ma14:wrappingTextBoxFlag xmlns="" xmlns:ma14="http://schemas.microsoft.com/office/mac/drawingml/2011/main" val="0"/>
             </a:ext>
           </a:extLst>
         </p:spPr>
@@ -14790,7 +15917,7 @@
           </a:prstGeom>
           <a:extLst>
             <a:ext uri="{C572A759-6A51-4108-AA02-DFA0A04FC94B}">
-              <ma14:wrappingTextBoxFlag xmlns:ma14="http://schemas.microsoft.com/office/mac/drawingml/2011/main" xmlns="" val="0"/>
+              <ma14:wrappingTextBoxFlag xmlns="" xmlns:ma14="http://schemas.microsoft.com/office/mac/drawingml/2011/main" val="0"/>
             </a:ext>
           </a:extLst>
         </p:spPr>
@@ -15674,7 +16801,7 @@
           </a:prstGeom>
           <a:extLst>
             <a:ext uri="{C572A759-6A51-4108-AA02-DFA0A04FC94B}">
-              <ma14:wrappingTextBoxFlag xmlns:ma14="http://schemas.microsoft.com/office/mac/drawingml/2011/main" xmlns="" val="0"/>
+              <ma14:wrappingTextBoxFlag xmlns="" xmlns:ma14="http://schemas.microsoft.com/office/mac/drawingml/2011/main" val="0"/>
             </a:ext>
           </a:extLst>
         </p:spPr>
@@ -16192,7 +17319,7 @@
           </a:prstGeom>
           <a:extLst>
             <a:ext uri="{C572A759-6A51-4108-AA02-DFA0A04FC94B}">
-              <ma14:wrappingTextBoxFlag xmlns:ma14="http://schemas.microsoft.com/office/mac/drawingml/2011/main" xmlns="" val="0"/>
+              <ma14:wrappingTextBoxFlag xmlns="" xmlns:ma14="http://schemas.microsoft.com/office/mac/drawingml/2011/main" val="0"/>
             </a:ext>
           </a:extLst>
         </p:spPr>
@@ -16867,7 +17994,7 @@
           </a:prstGeom>
           <a:extLst>
             <a:ext uri="{C572A759-6A51-4108-AA02-DFA0A04FC94B}">
-              <ma14:wrappingTextBoxFlag xmlns:ma14="http://schemas.microsoft.com/office/mac/drawingml/2011/main" xmlns="" val="0"/>
+              <ma14:wrappingTextBoxFlag xmlns="" xmlns:ma14="http://schemas.microsoft.com/office/mac/drawingml/2011/main" val="0"/>
             </a:ext>
           </a:extLst>
         </p:spPr>
@@ -17307,7 +18434,7 @@
           </a:prstGeom>
           <a:extLst>
             <a:ext uri="{C572A759-6A51-4108-AA02-DFA0A04FC94B}">
-              <ma14:wrappingTextBoxFlag xmlns:ma14="http://schemas.microsoft.com/office/mac/drawingml/2011/main" xmlns="" val="0"/>
+              <ma14:wrappingTextBoxFlag xmlns="" xmlns:ma14="http://schemas.microsoft.com/office/mac/drawingml/2011/main" val="0"/>
             </a:ext>
           </a:extLst>
         </p:spPr>

</xml_diff>